<commit_message>
Correct Muneeb's name and give both teammates their real roles
The deck, the vision PDF, both social cards, the post copy and the video end
cards all read "Muneed". It is Muhammad Muneeb, and he is the backend, data
and API developer; Inshrah Mehmood leads marketing and outreach. The two
"[ Add focus area ]" slots are now filled from what the team actually did
rather than left blank.

Videos carry the old spelling in their burned-in end cards and are being
re-rendered separately.

Co-Authored-By: Claude Opus 5 <noreply@anthropic.com>
</commit_message>
<xml_diff>
--- a/deliverables/TwinVerse_Inspect_AI_Pitch.pptx
+++ b/deliverables/TwinVerse_Inspect_AI_Pitch.pptx
@@ -2936,7 +2936,7 @@
                 <a:ea typeface="Calibri" pitchFamily="34" charset="-122"/>
                 <a:cs typeface="Calibri" pitchFamily="34" charset="-120"/>
               </a:rPr>
-              <a:t>Muhammad Muneed</a:t>
+              <a:t>Muhammad Muneeb</a:t>
             </a:r>
             <a:endParaRPr lang="en-US" sz="1400" dirty="0"/>
           </a:p>
@@ -2975,7 +2975,7 @@
                 <a:ea typeface="Calibri" pitchFamily="34" charset="-122"/>
                 <a:cs typeface="Calibri" pitchFamily="34" charset="-120"/>
               </a:rPr>
-              <a:t>Team Member</a:t>
+              <a:t>Backend, Data &amp; API</a:t>
             </a:r>
             <a:endParaRPr lang="en-US" sz="1150" dirty="0"/>
           </a:p>
@@ -3073,7 +3073,7 @@
                 <a:ea typeface="Calibri" pitchFamily="34" charset="-122"/>
                 <a:cs typeface="Calibri" pitchFamily="34" charset="-120"/>
               </a:rPr>
-              <a:t>Team Member</a:t>
+              <a:t>Marketing &amp; Outreach</a:t>
             </a:r>
             <a:endParaRPr lang="en-US" sz="1150" dirty="0"/>
           </a:p>
@@ -4625,7 +4625,7 @@
                 <a:ea typeface="Calibri" pitchFamily="34" charset="-122"/>
                 <a:cs typeface="Calibri" pitchFamily="34" charset="-120"/>
               </a:rPr>
-              <a:t>Muhammad Muneed</a:t>
+              <a:t>Muhammad Muneeb</a:t>
             </a:r>
             <a:endParaRPr lang="en-US" sz="1600" dirty="0"/>
           </a:p>
@@ -4664,7 +4664,7 @@
                 <a:ea typeface="Calibri" pitchFamily="34" charset="-122"/>
                 <a:cs typeface="Calibri" pitchFamily="34" charset="-120"/>
               </a:rPr>
-              <a:t>Team Member</a:t>
+              <a:t>Backend, Data &amp; API</a:t>
             </a:r>
             <a:endParaRPr lang="en-US" sz="1200" dirty="0"/>
           </a:p>
@@ -4694,6 +4694,17 @@
             <a:pPr algn="ctr" indent="0" marL="0">
               <a:buNone/>
             </a:pPr>
+            <a:r>
+              <a:rPr lang="en-US" sz="1150" dirty="0">
+                <a:solidFill>
+                  <a:srgbClr val="9FB0CC"/>
+                </a:solidFill>
+                <a:latin typeface="Calibri" pitchFamily="34" charset="0"/>
+                <a:ea typeface="Calibri" pitchFamily="34" charset="-122"/>
+                <a:cs typeface="Calibri" pitchFamily="34" charset="-120"/>
+              </a:rPr>
+              <a:t>Services, database and the upload pipeline</a:t>
+            </a:r>
             <a:endParaRPr lang="en-US" sz="1150" dirty="0"/>
           </a:p>
         </p:txBody>
@@ -4872,7 +4883,7 @@
                 <a:ea typeface="Calibri" pitchFamily="34" charset="-122"/>
                 <a:cs typeface="Calibri" pitchFamily="34" charset="-120"/>
               </a:rPr>
-              <a:t>Team Member</a:t>
+              <a:t>Marketing &amp; Outreach</a:t>
             </a:r>
             <a:endParaRPr lang="en-US" sz="1200" dirty="0"/>
           </a:p>
@@ -4902,6 +4913,17 @@
             <a:pPr algn="ctr" indent="0" marL="0">
               <a:buNone/>
             </a:pPr>
+            <a:r>
+              <a:rPr lang="en-US" sz="1150" dirty="0">
+                <a:solidFill>
+                  <a:srgbClr val="9FB0CC"/>
+                </a:solidFill>
+                <a:latin typeface="Calibri" pitchFamily="34" charset="0"/>
+                <a:ea typeface="Calibri" pitchFamily="34" charset="-122"/>
+                <a:cs typeface="Calibri" pitchFamily="34" charset="-120"/>
+              </a:rPr>
+              <a:t>Positioning, launch material and the pitch</a:t>
+            </a:r>
             <a:endParaRPr lang="en-US" sz="1150" dirty="0"/>
           </a:p>
         </p:txBody>
@@ -6121,7 +6143,7 @@
                 <a:ea typeface="Calibri" pitchFamily="34" charset="-122"/>
                 <a:cs typeface="Calibri" pitchFamily="34" charset="-120"/>
               </a:rPr>
-              <a:t>Ayaan Aatif  ·  Muhammad Muneed  ·  Inshrah Mehmood</a:t>
+              <a:t>Ayaan Aatif  ·  Muhammad Muneeb  ·  Inshrah Mehmood</a:t>
             </a:r>
             <a:endParaRPr lang="en-US" sz="1400" dirty="0"/>
           </a:p>

</xml_diff>